<commit_message>
docs(presentation): update pptx for eq/tot/MCP completion
Updates to slides 3 (module table), 6 (Phase F), 14 (summary),
15 (remaining work), and the title bar:
- All 7 modules now show "完了" (eq L-0..L-7 + F-1..F-5, tot L-0..L-7)
- MCP servers: 5 → 6 (tot MCP added)
- PR count: 86 → 96+
- Phase F-4 / F-5 rows annotated with PRs #87 / #93
- Remaining work list refreshed: trlib plot/TOML horizontal extension,
  MCP plot tool, tutorial notebooks (Jupyter), per-module Fortran
  README, tot optimization driver, MCP user manual

Regenerated 18-slide pptx via _build_pptx.py.

Co-Authored-By: Claude Opus 4.7 (1M context) <noreply@anthropic.com>
</commit_message>
<xml_diff>
--- a/docs/presentations/2026-04-19-task-library-ization-overview.pptx
+++ b/docs/presentations/2026-04-19-task-library-ization-overview.pptx
@@ -869,7 +869,7 @@
           <a:lstStyle/>
           <a:p>
             <a:r>
-              <a:t>(想定 1 分) ここまでの成果を数字でまとめます。merged PR は 86 件、対象モジュールは 7 つ、各モジュール 28+ のテストケースを整備しました。MCP ツールは 9 種類 × 5 モジュール (tr/fp/ti/wr/wrx) で展開済みです。ドキュメントとして、再利用可能な SKILL.md と日本語マニュアル PDF も整備しました。重要なのは下段の通り、CLI バイナリは一切変更していない点です。共有ライブラリは純粋な追加機能であり、従来のユーザに何の影響も与えません。</a:t>
+              <a:t>(想定 1 分) ここまでの成果を数字でまとめます。merged PR は 96 件超、対象モジュール 7 つ全て Phase L-0..L-7 完了、各モジュール 28+ のテストケースを整備しました。MCP ツールは 9 種類 × 6 サーバ (tr/fp/ti/wr/wrx/tot) で展開済みです。ドキュメントとして、再利用可能な SKILL.md と日本語マニュアル PDF (55 ページ) も整備しました。重要なのは下段の通り、CLI バイナリは一切変更していない点です。共有ライブラリは純粋な追加機能であり、従来のユーザに何の影響も与えません。</a:t>
             </a:r>
           </a:p>
         </p:txBody>
@@ -1289,7 +1289,7 @@
           <a:lstStyle/>
           <a:p>
             <a:r>
-              <a:t>(想定 1 分) 対象は 7 モジュールです。tr / fp / ti / wr / wrx の 5 つは Phase L-0 から L-7、そして MCP サーバまで完了しています。eq は MHD 平衡計算で、F77 のレガシーコードが多いためPhase F (F90 化) も並行して走らせており、L-5 まで到達。tot は他モジュールを束ねるトップレベルなので少し趣が違い、L-4 (.so ビルド) まで完了しています。残作業は後ほどスライド 15 で整理します。</a:t>
+              <a:t>(想定 1 分) 対象は 7 モジュールすべてが Phase L-0 から L-7、そして MCP サーバまで完了しました。eq は MHD 平衡計算で、F77 のレガシーコードが多かったため、Phase F (F-1..F-5 で F90 化 + shim 削除) も完了。tot は他 6 モジュールを namespace prefix (eq: / tr: 等) で束ねるオーケストレータで、L-5 Python wrapper + MCP まで完成。残作業は trlib の plot+TOML runner を他モジュールに横展開する作業のみ (スライド 15 参照)。</a:t>
             </a:r>
           </a:p>
         </p:txBody>
@@ -4983,7 +4983,7 @@
                 </a:solidFill>
                 <a:latin typeface="Noto Sans CJK JP"/>
               </a:rPr>
-              <a:t>Phase L-0 〜 L-7 / Phase F-1 〜 F-4 / MCP サーバ / 86 PR merge</a:t>
+              <a:t>Phase L-0 〜 L-7 / Phase F-1 〜 F-5 / MCP サーバ / 96 PR merge</a:t>
             </a:r>
           </a:p>
         </p:txBody>
@@ -6802,7 +6802,6 @@
               <a:t>登録コマンド + 利用イメージ</a:t>
             </a:r>
           </a:p>
-          <a:p/>
           <a:p>
             <a:r>
               <a:rPr sz="1200">
@@ -7976,7 +7975,7 @@
                 </a:solidFill>
                 <a:latin typeface="Noto Sans CJK JP"/>
               </a:rPr>
-              <a:t>86</a:t>
+              <a:t>96+</a:t>
             </a:r>
           </a:p>
           <a:p>
@@ -8000,7 +7999,7 @@
                 </a:solidFill>
                 <a:latin typeface="Noto Sans CJK JP"/>
               </a:rPr>
-              <a:t>PR #1 〜 #86</a:t>
+              <a:t>PR #1 〜 #96</a:t>
             </a:r>
           </a:p>
         </p:txBody>
@@ -8076,7 +8075,7 @@
                 </a:solidFill>
                 <a:latin typeface="Noto Sans CJK JP"/>
               </a:rPr>
-              <a:t>tr/fp/ti/wr/wrx/eq/tot</a:t>
+              <a:t>全 module 完了</a:t>
             </a:r>
           </a:p>
         </p:txBody>
@@ -8204,7 +8203,7 @@
                 </a:solidFill>
                 <a:latin typeface="Noto Sans CJK JP"/>
               </a:rPr>
-              <a:t>9</a:t>
+              <a:t>9 × 6</a:t>
             </a:r>
           </a:p>
           <a:p>
@@ -8216,7 +8215,7 @@
                 </a:solidFill>
                 <a:latin typeface="Noto Sans CJK JP"/>
               </a:rPr>
-              <a:t>MCP ツール × 5</a:t>
+              <a:t>MCP ツール × server</a:t>
             </a:r>
           </a:p>
           <a:p>
@@ -8228,7 +8227,7 @@
                 </a:solidFill>
                 <a:latin typeface="Noto Sans CJK JP"/>
               </a:rPr>
-              <a:t>tr/fp/ti/wr/wrx 横展開</a:t>
+              <a:t>tr/fp/ti/wr/wrx/tot</a:t>
             </a:r>
           </a:p>
         </p:txBody>
@@ -8560,7 +8559,7 @@
                 </a:solidFill>
                 <a:latin typeface="Noto Sans CJK JP"/>
               </a:rPr>
-              <a:t>・ eq モジュール: L-6 (4 層テスト) と L-7 (ドキュメント) を完了させる。</a:t>
+              <a:t>・ 可視化 API: trlib に plot(varname) + TOML runner reference 実装中 (PR #83) → fp/ti/wr/wrx/eq/tot に横展開。</a:t>
             </a:r>
           </a:p>
           <a:p>
@@ -8576,7 +8575,7 @@
                 </a:solidFill>
                 <a:latin typeface="Noto Sans CJK JP"/>
               </a:rPr>
-              <a:t>・ tot モジュール: L-5 (Python wrapper) / L-6 / L-7 を順次。コンポジット特有の API 設計が課題。</a:t>
+              <a:t>・ TOML config runner: python -m &lt;X&gt;lib config.toml を全モジュールに展開。</a:t>
             </a:r>
           </a:p>
           <a:p>
@@ -8592,7 +8591,7 @@
                 </a:solidFill>
                 <a:latin typeface="Noto Sans CJK JP"/>
               </a:rPr>
-              <a:t>・ Phase F-4 / F-5: eq の HIGH tier F90 化と shim 撤去 (grep clean-up)。</a:t>
+              <a:t>・ MCP plot ツール: base64 PNG 返却を 6 サーバ全部に追加 (plot/plot_sweep/plot_available)。</a:t>
             </a:r>
           </a:p>
           <a:p>
@@ -8608,7 +8607,7 @@
                 </a:solidFill>
                 <a:latin typeface="Noto Sans CJK JP"/>
               </a:rPr>
-              <a:t>・ 可視化 API: 各モジュールに plot(varname) を実装 (TR 先行 → fp / ti / wr 横展開)。</a:t>
+              <a:t>・ Tutorial notebooks: Jupyter で利用シナリオ別に整備 (parameter sweep / 最適化 / LLM 連携)。</a:t>
             </a:r>
           </a:p>
           <a:p>
@@ -8624,7 +8623,7 @@
                 </a:solidFill>
                 <a:latin typeface="Noto Sans CJK JP"/>
               </a:rPr>
-              <a:t>・ TOML config runner: python -m &lt;X&gt;lib config.toml を全モジュールへ。</a:t>
+              <a:t>・ Per-module Fortran-side README: 設計方針・invariant 集約 (English)。</a:t>
             </a:r>
           </a:p>
           <a:p>
@@ -8640,7 +8639,7 @@
                 </a:solidFill>
                 <a:latin typeface="Noto Sans CJK JP"/>
               </a:rPr>
-              <a:t>・ MCP plot ツール: base64 PNG 返却を 5 サーバ全部に追加。</a:t>
+              <a:t>・ tot 最適化ドライバ: scipy/optuna 連携 (元 L-7 plan の延長)。</a:t>
             </a:r>
           </a:p>
           <a:p>
@@ -8656,23 +8655,7 @@
                 </a:solidFill>
                 <a:latin typeface="Noto Sans CJK JP"/>
               </a:rPr>
-              <a:t>・ Tutorial notebooks: Jupyter で利用シナリオ別に整備 (parameter sweep / 最適化 / LLM)。</a:t>
-            </a:r>
-          </a:p>
-          <a:p>
-            <a:pPr algn="l">
-              <a:spcAft>
-                <a:spcPts val="600"/>
-              </a:spcAft>
-            </a:pPr>
-            <a:r>
-              <a:rPr sz="1500">
-                <a:solidFill>
-                  <a:srgbClr val="101010"/>
-                </a:solidFill>
-                <a:latin typeface="Noto Sans CJK JP"/>
-              </a:rPr>
-              <a:t>・ draft の plan PR 6 件を最新 develop にリベースして merge ready 化。</a:t>
+              <a:t>・ MCP 利用マニュアル: 素人向け、Claude Desktop / Cursor 登録手順含む。</a:t>
             </a:r>
           </a:p>
         </p:txBody>
@@ -11523,7 +11506,7 @@
                           </a:solidFill>
                           <a:latin typeface="Noto Sans CJK JP"/>
                         </a:rPr>
-                        <a:t>L-0..L-5</a:t>
+                        <a:t>完了</a:t>
                       </a:r>
                     </a:p>
                   </a:txBody>
@@ -11546,7 +11529,7 @@
                           </a:solidFill>
                           <a:latin typeface="Noto Sans CJK JP"/>
                         </a:rPr>
-                        <a:t>F-1..F-3 完了</a:t>
+                        <a:t>F-1..F-5 完了</a:t>
                       </a:r>
                     </a:p>
                   </a:txBody>
@@ -11592,7 +11575,7 @@
                           </a:solidFill>
                           <a:latin typeface="Noto Sans CJK JP"/>
                         </a:rPr>
-                        <a:t>L-6/L-7 残作業</a:t>
+                        <a:t>F90 modernization も完了</a:t>
                       </a:r>
                     </a:p>
                   </a:txBody>
@@ -11663,7 +11646,7 @@
                           </a:solidFill>
                           <a:latin typeface="Noto Sans CJK JP"/>
                         </a:rPr>
-                        <a:t>L-0..L-4</a:t>
+                        <a:t>完了</a:t>
                       </a:r>
                     </a:p>
                   </a:txBody>
@@ -11709,7 +11692,7 @@
                           </a:solidFill>
                           <a:latin typeface="Noto Sans CJK JP"/>
                         </a:rPr>
-                        <a:t>未着手</a:t>
+                        <a:t>完了</a:t>
                       </a:r>
                     </a:p>
                   </a:txBody>
@@ -11732,7 +11715,7 @@
                           </a:solidFill>
                           <a:latin typeface="Noto Sans CJK JP"/>
                         </a:rPr>
-                        <a:t>他モジュールのコンポジット</a:t>
+                        <a:t>namespace dispatch (eq:RR 等)</a:t>
                       </a:r>
                     </a:p>
                   </a:txBody>
@@ -13906,7 +13889,7 @@
                 </a:solidFill>
                 <a:latin typeface="Noto Sans CJK JP"/>
               </a:rPr>
-              <a:t>・ Phase F-4: HIGH tier (進行中) — file I/O や driver の F90 化。</a:t>
+              <a:t>・ Phase F-4: HIGH tier (PR #87) — file I/O や driver の F90 化 (8 ファイル)。</a:t>
             </a:r>
           </a:p>
           <a:p>
@@ -13922,7 +13905,7 @@
                 </a:solidFill>
                 <a:latin typeface="Noto Sans CJK JP"/>
               </a:rPr>
-              <a:t>・ Phase F-5: shim removal + grep clean-up (予定) — 旧 INCLUDE を完全撤去。</a:t>
+              <a:t>・ Phase F-5: shim removal (PR #93) — eqcom{c,m,q,x}.inc 撤去 + grep clean。</a:t>
             </a:r>
           </a:p>
           <a:p>
@@ -15214,7 +15197,6 @@
               <a:t>quickstart.py 抜粋</a:t>
             </a:r>
           </a:p>
-          <a:p/>
           <a:p>
             <a:r>
               <a:rPr sz="1400">

</xml_diff>